<commit_message>
Update slide 4: six rows, verified proof points
Co-Authored-By: Devin AI <158243242+devin-ai-integration[bot]@users.noreply.github.com>
</commit_message>
<xml_diff>
--- a/pitch/Cognition_Devin_CapitalOne_Deck.pptx
+++ b/pitch/Cognition_Devin_CapitalOne_Deck.pptx
@@ -4257,7 +4257,7 @@
           <a:lstStyle/>
           <a:p>
             <a:r>
-              <a:t>This is the bridge slide. Each row is one initiative you recapped; the third column names the Devin surface you will demo for it. Say explicitly: 'Everything in the demo maps to a row on this table.' If the CIO named a different constraint on the recap slide, add it verbally here as row six.</a:t>
+              <a:t>This is the bridge slide. Each row is one initiative you recapped; the third column names the Devin surface you will demo for it. Say explicitly: 'Everything in the demo maps to a row on this table.' If the CIO named a different constraint on the recap slide, add it verbally. Row six is Capital One's own open-source autonomous-PR harness (github.com/capitalone/context-specs): ask what has been hardest about scaling it.</a:t>
             </a:r>
           </a:p>
         </p:txBody>
@@ -34526,7 +34526,7 @@
         <p:spPr>
           <a:xfrm>
             <a:off x="548640" y="2148840"/>
-            <a:ext cx="11109960" cy="822960"/>
+            <a:ext cx="11109960" cy="713232"/>
           </a:xfrm>
           <a:prstGeom prst="rect">
             <a:avLst/>
@@ -34570,7 +34570,7 @@
         <p:spPr>
           <a:xfrm>
             <a:off x="640080" y="2148840"/>
-            <a:ext cx="2514600" cy="822960"/>
+            <a:ext cx="2514600" cy="713232"/>
           </a:xfrm>
           <a:prstGeom prst="rect">
             <a:avLst/>
@@ -34585,7 +34585,7 @@
           <a:p>
             <a:pPr algn="l"/>
             <a:r>
-              <a:rPr sz="1050" b="1" i="0">
+              <a:rPr sz="950" b="1" i="0">
                 <a:solidFill>
                   <a:srgbClr val="141B2D"/>
                 </a:solidFill>
@@ -34605,7 +34605,7 @@
         <p:spPr>
           <a:xfrm>
             <a:off x="3337560" y="2148840"/>
-            <a:ext cx="2880360" cy="822960"/>
+            <a:ext cx="2880360" cy="713232"/>
           </a:xfrm>
           <a:prstGeom prst="rect">
             <a:avLst/>
@@ -34620,13 +34620,13 @@
           <a:p>
             <a:pPr algn="l"/>
             <a:r>
-              <a:rPr sz="1050" b="0" i="0">
+              <a:rPr sz="950" b="0" i="0">
                 <a:solidFill>
                   <a:srgbClr val="141B2D"/>
                 </a:solidFill>
                 <a:latin typeface="Calibri"/>
               </a:rPr>
-              <a:t>Thousands of services to migrate, re-platform, re-test; duplicated systems to retire</a:t>
+              <a:t>Portfolio converts in waves to Jan 2027; services to migrate, re-platform, re-test; legacy and vendor connections to retire</a:t>
             </a:r>
           </a:p>
         </p:txBody>
@@ -34640,7 +34640,7 @@
         <p:spPr>
           <a:xfrm>
             <a:off x="6400800" y="2148840"/>
-            <a:ext cx="2880360" cy="822960"/>
+            <a:ext cx="2880360" cy="713232"/>
           </a:xfrm>
           <a:prstGeom prst="rect">
             <a:avLst/>
@@ -34655,13 +34655,13 @@
           <a:p>
             <a:pPr algn="l"/>
             <a:r>
-              <a:rPr sz="1050" b="0" i="0">
+              <a:rPr sz="950" b="0" i="0">
                 <a:solidFill>
                   <a:srgbClr val="3B82F6"/>
                 </a:solidFill>
                 <a:latin typeface="Calibri"/>
               </a:rPr>
-              <a:t>Sessions at scale: parallel migration PRs against a playbook, each tested and reviewed (Nubank did this 12x faster)</a:t>
+              <a:t>Sessions at scale: parallel migration PRs from one playbook (Itau: .NET to Java 6x faster, 5x cheaper; Nubank: 8-12x faster, 20x cheaper)</a:t>
             </a:r>
           </a:p>
         </p:txBody>
@@ -34675,7 +34675,7 @@
         <p:spPr>
           <a:xfrm>
             <a:off x="9464040" y="2148840"/>
-            <a:ext cx="2148840" cy="822960"/>
+            <a:ext cx="2148840" cy="713232"/>
           </a:xfrm>
           <a:prstGeom prst="rect">
             <a:avLst/>
@@ -34690,13 +34690,13 @@
           <a:p>
             <a:pPr algn="l"/>
             <a:r>
-              <a:rPr sz="1050" b="0" i="0">
+              <a:rPr sz="950" b="0" i="0">
                 <a:solidFill>
                   <a:srgbClr val="141B2D"/>
                 </a:solidFill>
                 <a:latin typeface="Calibri"/>
               </a:rPr>
-              <a:t>Integration synergies realised sooner; engineers freed for customer work</a:t>
+              <a:t>$1.5B synergies, two-thirds still gated on tech conversion, pulled forward</a:t>
             </a:r>
           </a:p>
         </p:txBody>
@@ -34709,8 +34709,8 @@
         </p:nvSpPr>
         <p:spPr>
           <a:xfrm>
-            <a:off x="640080" y="2971800"/>
-            <a:ext cx="2514600" cy="822960"/>
+            <a:off x="640080" y="2862072"/>
+            <a:ext cx="2514600" cy="713232"/>
           </a:xfrm>
           <a:prstGeom prst="rect">
             <a:avLst/>
@@ -34725,7 +34725,7 @@
           <a:p>
             <a:pPr algn="l"/>
             <a:r>
-              <a:rPr sz="1050" b="1" i="0">
+              <a:rPr sz="950" b="1" i="0">
                 <a:solidFill>
                   <a:srgbClr val="141B2D"/>
                 </a:solidFill>
@@ -34744,8 +34744,8 @@
         </p:nvSpPr>
         <p:spPr>
           <a:xfrm>
-            <a:off x="3337560" y="2971800"/>
-            <a:ext cx="2880360" cy="822960"/>
+            <a:off x="3337560" y="2862072"/>
+            <a:ext cx="2880360" cy="713232"/>
           </a:xfrm>
           <a:prstGeom prst="rect">
             <a:avLst/>
@@ -34760,13 +34760,13 @@
           <a:p>
             <a:pPr algn="l"/>
             <a:r>
-              <a:rPr sz="1050" b="0" i="0">
+              <a:rPr sz="950" b="0" i="0">
                 <a:solidFill>
                   <a:srgbClr val="141B2D"/>
                 </a:solidFill>
                 <a:latin typeface="Calibri"/>
               </a:rPr>
-              <a:t>Sensitive-data detection, lineage, and compliance tooling that must keep pace with new data</a:t>
+              <a:t>Sensitive-data tooling, lineage and compliance evidence that must keep pace with new data</a:t>
             </a:r>
           </a:p>
         </p:txBody>
@@ -34779,8 +34779,8 @@
         </p:nvSpPr>
         <p:spPr>
           <a:xfrm>
-            <a:off x="6400800" y="2971800"/>
-            <a:ext cx="2880360" cy="822960"/>
+            <a:off x="6400800" y="2862072"/>
+            <a:ext cx="2880360" cy="713232"/>
           </a:xfrm>
           <a:prstGeom prst="rect">
             <a:avLst/>
@@ -34795,13 +34795,13 @@
           <a:p>
             <a:pPr algn="l"/>
             <a:r>
-              <a:rPr sz="1050" b="0" i="0">
+              <a:rPr sz="950" b="0" i="0">
                 <a:solidFill>
                   <a:srgbClr val="3B82F6"/>
                 </a:solidFill>
                 <a:latin typeface="Calibri"/>
               </a:rPr>
-              <a:t>Sessions + Review on data tooling (e.g. DataProfiler): new detectors, tests, and a second reviewer on every PR</a:t>
+              <a:t>Sessions + Review on data tooling (e.g. DataProfiler); Wiki as audit-ready system documentation (Itau: 300k repos)</a:t>
             </a:r>
           </a:p>
         </p:txBody>
@@ -34814,8 +34814,8 @@
         </p:nvSpPr>
         <p:spPr>
           <a:xfrm>
-            <a:off x="9464040" y="2971800"/>
-            <a:ext cx="2148840" cy="822960"/>
+            <a:off x="9464040" y="2862072"/>
+            <a:ext cx="2148840" cy="713232"/>
           </a:xfrm>
           <a:prstGeom prst="rect">
             <a:avLst/>
@@ -34830,7 +34830,7 @@
           <a:p>
             <a:pPr algn="l"/>
             <a:r>
-              <a:rPr sz="1050" b="0" i="0">
+              <a:rPr sz="950" b="0" i="0">
                 <a:solidFill>
                   <a:srgbClr val="141B2D"/>
                 </a:solidFill>
@@ -34849,8 +34849,8 @@
         </p:nvSpPr>
         <p:spPr>
           <a:xfrm>
-            <a:off x="548640" y="3794760"/>
-            <a:ext cx="11109960" cy="822960"/>
+            <a:off x="548640" y="3575304"/>
+            <a:ext cx="11109960" cy="713232"/>
           </a:xfrm>
           <a:prstGeom prst="rect">
             <a:avLst/>
@@ -34893,8 +34893,8 @@
         </p:nvSpPr>
         <p:spPr>
           <a:xfrm>
-            <a:off x="640080" y="3794760"/>
-            <a:ext cx="2514600" cy="822960"/>
+            <a:off x="640080" y="3575304"/>
+            <a:ext cx="2514600" cy="713232"/>
           </a:xfrm>
           <a:prstGeom prst="rect">
             <a:avLst/>
@@ -34909,7 +34909,7 @@
           <a:p>
             <a:pPr algn="l"/>
             <a:r>
-              <a:rPr sz="1050" b="1" i="0">
+              <a:rPr sz="950" b="1" i="0">
                 <a:solidFill>
                   <a:srgbClr val="141B2D"/>
                 </a:solidFill>
@@ -34928,8 +34928,8 @@
         </p:nvSpPr>
         <p:spPr>
           <a:xfrm>
-            <a:off x="3337560" y="3794760"/>
-            <a:ext cx="2880360" cy="822960"/>
+            <a:off x="3337560" y="3575304"/>
+            <a:ext cx="2880360" cy="713232"/>
           </a:xfrm>
           <a:prstGeom prst="rect">
             <a:avLst/>
@@ -34944,13 +34944,13 @@
           <a:p>
             <a:pPr algn="l"/>
             <a:r>
-              <a:rPr sz="1050" b="0" i="0">
+              <a:rPr sz="950" b="0" i="0">
                 <a:solidFill>
                   <a:srgbClr val="141B2D"/>
                 </a:solidFill>
                 <a:latin typeface="Calibri"/>
               </a:rPr>
-              <a:t>CVE patches, library upgrades and deprecations across thousands of Python and Java repos</a:t>
+              <a:t>CVEs, scanner findings and library upgrades across the Java, Python and Go estate</a:t>
             </a:r>
           </a:p>
         </p:txBody>
@@ -34963,8 +34963,8 @@
         </p:nvSpPr>
         <p:spPr>
           <a:xfrm>
-            <a:off x="6400800" y="3794760"/>
-            <a:ext cx="2880360" cy="822960"/>
+            <a:off x="6400800" y="3575304"/>
+            <a:ext cx="2880360" cy="713232"/>
           </a:xfrm>
           <a:prstGeom prst="rect">
             <a:avLst/>
@@ -34979,13 +34979,13 @@
           <a:p>
             <a:pPr algn="l"/>
             <a:r>
-              <a:rPr sz="1050" b="0" i="0">
+              <a:rPr sz="950" b="0" i="0">
                 <a:solidFill>
                   <a:srgbClr val="3B82F6"/>
                 </a:solidFill>
                 <a:latin typeface="Calibri"/>
               </a:rPr>
-              <a:t>Automations: scheduled dependency and CVE sweeps that open PRs and report to Slack</a:t>
+              <a:t>Security Swarm + Automations: find, prove exploitable, fix; weekly CVE sweeps (Itau: ~70% of findings auto-remediated)</a:t>
             </a:r>
           </a:p>
         </p:txBody>
@@ -34998,8 +34998,8 @@
         </p:nvSpPr>
         <p:spPr>
           <a:xfrm>
-            <a:off x="9464040" y="3794760"/>
-            <a:ext cx="2148840" cy="822960"/>
+            <a:off x="9464040" y="3575304"/>
+            <a:ext cx="2148840" cy="713232"/>
           </a:xfrm>
           <a:prstGeom prst="rect">
             <a:avLst/>
@@ -35014,13 +35014,13 @@
           <a:p>
             <a:pPr algn="l"/>
             <a:r>
-              <a:rPr sz="1050" b="0" i="0">
+              <a:rPr sz="950" b="0" i="0">
                 <a:solidFill>
                   <a:srgbClr val="141B2D"/>
                 </a:solidFill>
                 <a:latin typeface="Calibri"/>
               </a:rPr>
-              <a:t>Mean time to patch drops from weeks to days, bank-wide</a:t>
+              <a:t>Mean time to patch from weeks to days, bank-wide</a:t>
             </a:r>
           </a:p>
         </p:txBody>
@@ -35033,8 +35033,8 @@
         </p:nvSpPr>
         <p:spPr>
           <a:xfrm>
-            <a:off x="640080" y="4617720"/>
-            <a:ext cx="2514600" cy="822960"/>
+            <a:off x="640080" y="4288536"/>
+            <a:ext cx="2514600" cy="713232"/>
           </a:xfrm>
           <a:prstGeom prst="rect">
             <a:avLst/>
@@ -35049,7 +35049,7 @@
           <a:p>
             <a:pPr algn="l"/>
             <a:r>
-              <a:rPr sz="1050" b="1" i="0">
+              <a:rPr sz="950" b="1" i="0">
                 <a:solidFill>
                   <a:srgbClr val="141B2D"/>
                 </a:solidFill>
@@ -35068,8 +35068,8 @@
         </p:nvSpPr>
         <p:spPr>
           <a:xfrm>
-            <a:off x="3337560" y="4617720"/>
-            <a:ext cx="2880360" cy="822960"/>
+            <a:off x="3337560" y="4288536"/>
+            <a:ext cx="2880360" cy="713232"/>
           </a:xfrm>
           <a:prstGeom prst="rect">
             <a:avLst/>
@@ -35084,13 +35084,13 @@
           <a:p>
             <a:pPr algn="l"/>
             <a:r>
-              <a:rPr sz="1050" b="0" i="0">
+              <a:rPr sz="950" b="0" i="0">
                 <a:solidFill>
                   <a:srgbClr val="141B2D"/>
                 </a:solidFill>
                 <a:latin typeface="Calibri"/>
               </a:rPr>
-              <a:t>Undocumented systems; senior engineers spend hours answering the same questions</a:t>
+              <a:t>Undocumented systems; senior engineers answering the same questions</a:t>
             </a:r>
           </a:p>
         </p:txBody>
@@ -35103,8 +35103,8 @@
         </p:nvSpPr>
         <p:spPr>
           <a:xfrm>
-            <a:off x="6400800" y="4617720"/>
-            <a:ext cx="2880360" cy="822960"/>
+            <a:off x="6400800" y="4288536"/>
+            <a:ext cx="2880360" cy="713232"/>
           </a:xfrm>
           <a:prstGeom prst="rect">
             <a:avLst/>
@@ -35119,13 +35119,13 @@
           <a:p>
             <a:pPr algn="l"/>
             <a:r>
-              <a:rPr sz="1050" b="0" i="0">
+              <a:rPr sz="950" b="0" i="0">
                 <a:solidFill>
                   <a:srgbClr val="3B82F6"/>
                 </a:solidFill>
                 <a:latin typeface="Calibri"/>
               </a:rPr>
-              <a:t>Wiki + Ask Devin: always-current architecture docs and Q&amp;A across both estates</a:t>
+              <a:t>Wiki + Ask Devin: always-current docs and Q&amp;A across both estates (Itau principals design ~10x faster)</a:t>
             </a:r>
           </a:p>
         </p:txBody>
@@ -35138,8 +35138,8 @@
         </p:nvSpPr>
         <p:spPr>
           <a:xfrm>
-            <a:off x="9464040" y="4617720"/>
-            <a:ext cx="2148840" cy="822960"/>
+            <a:off x="9464040" y="4288536"/>
+            <a:ext cx="2148840" cy="713232"/>
           </a:xfrm>
           <a:prstGeom prst="rect">
             <a:avLst/>
@@ -35154,13 +35154,13 @@
           <a:p>
             <a:pPr algn="l"/>
             <a:r>
-              <a:rPr sz="1050" b="0" i="0">
+              <a:rPr sz="950" b="0" i="0">
                 <a:solidFill>
                   <a:srgbClr val="141B2D"/>
                 </a:solidFill>
                 <a:latin typeface="Calibri"/>
               </a:rPr>
-              <a:t>Faster onboarding, fewer interrupts, knowledge retained through attrition</a:t>
+              <a:t>Faster onboarding, fewer interrupts, knowledge kept through attrition</a:t>
             </a:r>
           </a:p>
         </p:txBody>
@@ -35173,8 +35173,8 @@
         </p:nvSpPr>
         <p:spPr>
           <a:xfrm>
-            <a:off x="548640" y="5440680"/>
-            <a:ext cx="11109960" cy="822960"/>
+            <a:off x="548640" y="5001768"/>
+            <a:ext cx="11109960" cy="713232"/>
           </a:xfrm>
           <a:prstGeom prst="rect">
             <a:avLst/>
@@ -35217,8 +35217,8 @@
         </p:nvSpPr>
         <p:spPr>
           <a:xfrm>
-            <a:off x="640080" y="5440680"/>
-            <a:ext cx="2514600" cy="822960"/>
+            <a:off x="640080" y="5001768"/>
+            <a:ext cx="2514600" cy="713232"/>
           </a:xfrm>
           <a:prstGeom prst="rect">
             <a:avLst/>
@@ -35233,7 +35233,7 @@
           <a:p>
             <a:pPr algn="l"/>
             <a:r>
-              <a:rPr sz="1050" b="1" i="0">
+              <a:rPr sz="950" b="1" i="0">
                 <a:solidFill>
                   <a:srgbClr val="141B2D"/>
                 </a:solidFill>
@@ -35252,8 +35252,8 @@
         </p:nvSpPr>
         <p:spPr>
           <a:xfrm>
-            <a:off x="3337560" y="5440680"/>
-            <a:ext cx="2880360" cy="822960"/>
+            <a:off x="3337560" y="5001768"/>
+            <a:ext cx="2880360" cy="713232"/>
           </a:xfrm>
           <a:prstGeom prst="rect">
             <a:avLst/>
@@ -35268,13 +35268,13 @@
           <a:p>
             <a:pPr algn="l"/>
             <a:r>
-              <a:rPr sz="1050" b="0" i="0">
+              <a:rPr sz="950" b="0" i="0">
                 <a:solidFill>
                   <a:srgbClr val="141B2D"/>
                 </a:solidFill>
                 <a:latin typeface="Calibri"/>
               </a:rPr>
-              <a:t>Every automated actor needs identity, scoped access, auditability, and data guarantees</a:t>
+              <a:t>Every automated actor needs identity, scoped access, auditability and data guarantees</a:t>
             </a:r>
           </a:p>
         </p:txBody>
@@ -35287,8 +35287,8 @@
         </p:nvSpPr>
         <p:spPr>
           <a:xfrm>
-            <a:off x="6400800" y="5440680"/>
-            <a:ext cx="2880360" cy="822960"/>
+            <a:off x="6400800" y="5001768"/>
+            <a:ext cx="2880360" cy="713232"/>
           </a:xfrm>
           <a:prstGeom prst="rect">
             <a:avLst/>
@@ -35303,13 +35303,13 @@
           <a:p>
             <a:pPr algn="l"/>
             <a:r>
-              <a:rPr sz="1050" b="0" i="0">
+              <a:rPr sz="950" b="0" i="0">
                 <a:solidFill>
                   <a:srgbClr val="3B82F6"/>
                 </a:solidFill>
                 <a:latin typeface="Calibri"/>
               </a:rPr>
-              <a:t>Security: VPC deployment, SSO/SCIM, scoped GitHub App, secrets vault, immutable session logs, no training on code</a:t>
+              <a:t>Security: VPC/single-tenant, SSO/SCIM, scoped GitHub App, secrets vault, replayable logs, no training on code; FedRAMP High In-Process; AWS partner</a:t>
             </a:r>
           </a:p>
         </p:txBody>
@@ -35322,8 +35322,8 @@
         </p:nvSpPr>
         <p:spPr>
           <a:xfrm>
-            <a:off x="9464040" y="5440680"/>
-            <a:ext cx="2148840" cy="822960"/>
+            <a:off x="9464040" y="5001768"/>
+            <a:ext cx="2148840" cy="713232"/>
           </a:xfrm>
           <a:prstGeom prst="rect">
             <a:avLst/>
@@ -35338,13 +35338,153 @@
           <a:p>
             <a:pPr algn="l"/>
             <a:r>
-              <a:rPr sz="1050" b="0" i="0">
+              <a:rPr sz="950" b="0" i="0">
                 <a:solidFill>
                   <a:srgbClr val="141B2D"/>
                 </a:solidFill>
                 <a:latin typeface="Calibri"/>
               </a:rPr>
-              <a:t>AI adoption Technology Risk can sign off on; peer precedent at Goldman Sachs</a:t>
+              <a:t>AI Technology Risk can sign off on; peer precedent at Goldman Sachs and Itau</a:t>
+            </a:r>
+          </a:p>
+        </p:txBody>
+      </p:sp>
+      <p:sp>
+        <p:nvSpPr>
+          <p:cNvPr id="34" name="TextBox 33"/>
+          <p:cNvSpPr txBox="1"/>
+          <p:nvPr/>
+        </p:nvSpPr>
+        <p:spPr>
+          <a:xfrm>
+            <a:off x="640080" y="5715000"/>
+            <a:ext cx="2514600" cy="713232"/>
+          </a:xfrm>
+          <a:prstGeom prst="rect">
+            <a:avLst/>
+          </a:prstGeom>
+          <a:noFill/>
+        </p:spPr>
+        <p:txBody>
+          <a:bodyPr wrap="square" anchor="ctr" lIns="45720" rIns="45720" tIns="27432" bIns="27432">
+            <a:spAutoFit/>
+          </a:bodyPr>
+          <a:lstStyle/>
+          <a:p>
+            <a:pPr algn="l"/>
+            <a:r>
+              <a:rPr sz="950" b="1" i="0">
+                <a:solidFill>
+                  <a:srgbClr val="141B2D"/>
+                </a:solidFill>
+                <a:latin typeface="Calibri"/>
+              </a:rPr>
+              <a:t>Scale autonomous engineering beyond Context Specs</a:t>
+            </a:r>
+          </a:p>
+        </p:txBody>
+      </p:sp>
+      <p:sp>
+        <p:nvSpPr>
+          <p:cNvPr id="35" name="TextBox 34"/>
+          <p:cNvSpPr txBox="1"/>
+          <p:nvPr/>
+        </p:nvSpPr>
+        <p:spPr>
+          <a:xfrm>
+            <a:off x="3337560" y="5715000"/>
+            <a:ext cx="2880360" cy="713232"/>
+          </a:xfrm>
+          <a:prstGeom prst="rect">
+            <a:avLst/>
+          </a:prstGeom>
+          <a:noFill/>
+        </p:spPr>
+        <p:txBody>
+          <a:bodyPr wrap="square" anchor="ctr" lIns="45720" rIns="45720" tIns="27432" bIns="27432">
+            <a:spAutoFit/>
+          </a:bodyPr>
+          <a:lstStyle/>
+          <a:p>
+            <a:pPr algn="l"/>
+            <a:r>
+              <a:rPr sz="950" b="0" i="0">
+                <a:solidFill>
+                  <a:srgbClr val="141B2D"/>
+                </a:solidFill>
+                <a:latin typeface="Calibri"/>
+              </a:rPr>
+              <a:t>Environments, long-term memory, review capacity and governance for a harness used by 14,000 engineers</a:t>
+            </a:r>
+          </a:p>
+        </p:txBody>
+      </p:sp>
+      <p:sp>
+        <p:nvSpPr>
+          <p:cNvPr id="36" name="TextBox 35"/>
+          <p:cNvSpPr txBox="1"/>
+          <p:nvPr/>
+        </p:nvSpPr>
+        <p:spPr>
+          <a:xfrm>
+            <a:off x="6400800" y="5715000"/>
+            <a:ext cx="2880360" cy="713232"/>
+          </a:xfrm>
+          <a:prstGeom prst="rect">
+            <a:avLst/>
+          </a:prstGeom>
+          <a:noFill/>
+        </p:spPr>
+        <p:txBody>
+          <a:bodyPr wrap="square" anchor="ctr" lIns="45720" rIns="45720" tIns="27432" bIns="27432">
+            <a:spAutoFit/>
+          </a:bodyPr>
+          <a:lstStyle/>
+          <a:p>
+            <a:pPr algn="l"/>
+            <a:r>
+              <a:rPr sz="950" b="0" i="0">
+                <a:solidFill>
+                  <a:srgbClr val="3B82F6"/>
+                </a:solidFill>
+                <a:latin typeface="Calibri"/>
+              </a:rPr>
+              <a:t>Managed harness: snapshots, Wiki/Knowledge/Playbooks, Review, enterprise controls, maintained by Cognition</a:t>
+            </a:r>
+          </a:p>
+        </p:txBody>
+      </p:sp>
+      <p:sp>
+        <p:nvSpPr>
+          <p:cNvPr id="37" name="TextBox 36"/>
+          <p:cNvSpPr txBox="1"/>
+          <p:nvPr/>
+        </p:nvSpPr>
+        <p:spPr>
+          <a:xfrm>
+            <a:off x="9464040" y="5715000"/>
+            <a:ext cx="2148840" cy="713232"/>
+          </a:xfrm>
+          <a:prstGeom prst="rect">
+            <a:avLst/>
+          </a:prstGeom>
+          <a:noFill/>
+        </p:spPr>
+        <p:txBody>
+          <a:bodyPr wrap="square" anchor="ctr" lIns="45720" rIns="45720" tIns="27432" bIns="27432">
+            <a:spAutoFit/>
+          </a:bodyPr>
+          <a:lstStyle/>
+          <a:p>
+            <a:pPr algn="l"/>
+            <a:r>
+              <a:rPr sz="950" b="0" i="0">
+                <a:solidFill>
+                  <a:srgbClr val="141B2D"/>
+                </a:solidFill>
+                <a:latin typeface="Calibri"/>
+              </a:rPr>
+              <a:t>The harness runs bank-wide, not on one team</a:t>
             </a:r>
           </a:p>
         </p:txBody>

</xml_diff>

<commit_message>
Retarget Capital One demo to Hygieia Java 11 to 17 upgrade
Co-Authored-By: Devin AI <158243242+devin-ai-integration[bot]@users.noreply.github.com>
</commit_message>
<xml_diff>
--- a/pitch/Cognition_Devin_CapitalOne_Deck.pptx
+++ b/pitch/Cognition_Devin_CapitalOne_Deck.pptx
@@ -4315,7 +4315,7 @@
           <a:lstStyle/>
           <a:p>
             <a:r>
-              <a:t>Pre-empt the 'toy repo' objection: this is Capital One's own library, used for sensitive-data detection. Note that the same workflow applies to any internal repo; DataProfiler is the one everyone in the room can see.</a:t>
+              <a:t>Pre-empt 'why an archived repo?': archived, author-less Java is precisely the modernization problem; Discover brings plenty of it. Hygieia is Capital One's own code, so the room recognises it. The same playbook applies to any internal Java service.</a:t>
             </a:r>
           </a:p>
         </p:txBody>
@@ -4373,7 +4373,7 @@
           <a:lstStyle/>
           <a:p>
             <a:r>
-              <a:t>Timing: ~15 minutes total. Start the Session FIRST (before demo steps 1-2) so it is finishing by the time you reach step 2; narrate the plan and the live PR. Always have a completed session and PR from the night before as a fallback. Call out the 'Ties to' line on each step out loud: that is what the exercise is grading.</a:t>
+              <a:t>Timing: ~15 minutes. Start the playbook session FIRST so it is well under way by step 2; the full upgrade takes longer than the demo, so narrate the completed sessions and PRs from your earlier run. Say the sequencing rule out loud (core before api, install locally, then api) because it is what makes this look like real engineering. Call out the 'Ties to' line on each step.</a:t>
             </a:r>
           </a:p>
         </p:txBody>
@@ -34801,7 +34801,7 @@
                 </a:solidFill>
                 <a:latin typeface="Calibri"/>
               </a:rPr>
-              <a:t>Sessions + Review on data tooling (e.g. DataProfiler); Wiki as audit-ready system documentation (Itau: 300k repos)</a:t>
+              <a:t>Sessions + Review on data and compliance tooling; Wiki as audit-ready system documentation (Itau: 300k repos)</a:t>
             </a:r>
           </a:p>
         </p:txBody>
@@ -35624,7 +35624,7 @@
                 </a:solidFill>
                 <a:latin typeface="Calibri"/>
               </a:rPr>
-              <a:t>Demo repo: capitalone/DataProfiler</a:t>
+              <a:t>Demo repo: Capital One's Hygieia</a:t>
             </a:r>
           </a:p>
         </p:txBody>
@@ -35694,7 +35694,7 @@
                 </a:solidFill>
                 <a:latin typeface="Calibri"/>
               </a:rPr>
-              <a:t>DataProfiler is Capital One's open-source Python library for profiling datasets and detecting sensitive data (PII / NPI) with a pre-trained ML model. It is the kind of tooling a bank runs on every new data source.</a:t>
+              <a:t>Hygieia is the open-source DevOps dashboard Capital One built and released in 2015: Java / Spring Boot services (hygieia-core, api) plus a fleet of collectors for Jenkins, GitHub, Sonar, Jira and more, on MongoDB.</a:t>
             </a:r>
           </a:p>
           <a:p>
@@ -35718,7 +35718,7 @@
                 </a:solidFill>
                 <a:latin typeface="Calibri"/>
               </a:rPr>
-              <a:t>It is a real, production-grade codebase: ~60k lines of Python, hundreds of tests, GitHub Actions CI across four Python versions, pre-commit linting, and commits this month. It is not a toy.</a:t>
+              <a:t>It is exactly what a bank's legacy estate looks like: Java 8/11, Spring Boot 1.5-2.x, old build plugins, a dependency chain across many repos, and no original authors left (the upstream org is archived).</a:t>
             </a:r>
           </a:p>
           <a:p>
@@ -35742,7 +35742,7 @@
                 </a:solidFill>
                 <a:latin typeface="Calibri"/>
               </a:rPr>
-              <a:t>And it sits at the intersection of the CIO and CISO agendas: data governance, privacy, and compliance evidence. Every improvement here is a control getting stronger.</a:t>
+              <a:t>The demo task is the one Goldman named on CNBC: 'updating internal code to newer languages.' Devin upgrades hygieia-core and api from Java 11 to Java 17 from a reusable playbook, fixing what breaks and keeping tests green.</a:t>
             </a:r>
           </a:p>
         </p:txBody>
@@ -35771,13 +35771,13 @@
           <a:p>
             <a:pPr algn="ctr"/>
             <a:r>
-              <a:rPr sz="3400" b="1" i="0">
+              <a:rPr sz="2200" b="1" i="0">
                 <a:solidFill>
                   <a:srgbClr val="D03027"/>
                 </a:solidFill>
                 <a:latin typeface="Calibri"/>
               </a:rPr>
-              <a:t>~60k</a:t>
+              <a:t>Java 11 to 17</a:t>
             </a:r>
           </a:p>
         </p:txBody>
@@ -35812,7 +35812,7 @@
                 </a:solidFill>
                 <a:latin typeface="Calibri"/>
               </a:rPr>
-              <a:t>lines of Python, ML labeler included</a:t>
+              <a:t>the upgrade every Discover and legacy service needs</a:t>
             </a:r>
           </a:p>
         </p:txBody>
@@ -35841,13 +35841,13 @@
           <a:p>
             <a:pPr algn="ctr"/>
             <a:r>
-              <a:rPr sz="2600" b="1" i="0">
+              <a:rPr sz="3000" b="1" i="0">
                 <a:solidFill>
                   <a:srgbClr val="D03027"/>
                 </a:solidFill>
                 <a:latin typeface="Calibri"/>
               </a:rPr>
-              <a:t>PII / NPI</a:t>
+              <a:t>2 repos</a:t>
             </a:r>
           </a:p>
         </p:txBody>
@@ -35882,7 +35882,7 @@
                 </a:solidFill>
                 <a:latin typeface="Calibri"/>
               </a:rPr>
-              <a:t>sensitive-data detection is its core job</a:t>
+              <a:t>core first, then api: a real dependency chain</a:t>
             </a:r>
           </a:p>
         </p:txBody>
@@ -35911,13 +35911,13 @@
           <a:p>
             <a:pPr algn="ctr"/>
             <a:r>
-              <a:rPr sz="3400" b="1" i="0">
+              <a:rPr sz="2200" b="1" i="0">
                 <a:solidFill>
                   <a:srgbClr val="D03027"/>
                 </a:solidFill>
                 <a:latin typeface="Calibri"/>
               </a:rPr>
-              <a:t>4</a:t>
+              <a:t>1 playbook</a:t>
             </a:r>
           </a:p>
         </p:txBody>
@@ -35952,7 +35952,7 @@
                 </a:solidFill>
                 <a:latin typeface="Calibri"/>
               </a:rPr>
-              <a:t>Python versions in CI, pre-commit enforced</a:t>
+              <a:t>written once, re-run on every collector</a:t>
             </a:r>
           </a:p>
         </p:txBody>
@@ -35981,13 +35981,13 @@
           <a:p>
             <a:pPr algn="ctr"/>
             <a:r>
-              <a:rPr sz="3400" b="1" i="0">
+              <a:rPr sz="3000" b="1" i="0">
                 <a:solidFill>
                   <a:srgbClr val="D03027"/>
                 </a:solidFill>
                 <a:latin typeface="Calibri"/>
               </a:rPr>
-              <a:t>Active</a:t>
+              <a:t>2015</a:t>
             </a:r>
           </a:p>
         </p:txBody>
@@ -36022,7 +36022,7 @@
                 </a:solidFill>
                 <a:latin typeface="Calibri"/>
               </a:rPr>
-              <a:t>maintained by Capital One engineers</a:t>
+              <a:t>built by Capital One; upstream now archived</a:t>
             </a:r>
           </a:p>
         </p:txBody>
@@ -36057,7 +36057,7 @@
                 </a:solidFill>
                 <a:latin typeface="Calibri"/>
               </a:rPr>
-              <a:t>github.com/capitalone/DataProfiler  |  In the demo, Devin works on a fork with the same code, tests, and CI.</a:t>
+              <a:t>github.com/Hygieia  |  Demo runs on forks of hygieia-core and api with the same code, tests, and CI.</a:t>
             </a:r>
           </a:p>
         </p:txBody>
@@ -36197,7 +36197,7 @@
                 </a:solidFill>
                 <a:latin typeface="Calibri"/>
               </a:rPr>
-              <a:t>Live demo: a day as a DataProfiler maintainer</a:t>
+              <a:t>Live demo: Java 11 to 17 on Hygieia</a:t>
             </a:r>
           </a:p>
         </p:txBody>
@@ -36349,7 +36349,7 @@
           <a:p>
             <a:pPr algn="l"/>
             <a:r>
-              <a:rPr sz="1500" b="1" i="0">
+              <a:rPr sz="1300" b="1" i="0">
                 <a:solidFill>
                   <a:srgbClr val="FFFFFF"/>
                 </a:solidFill>
@@ -36369,7 +36369,7 @@
         <p:spPr>
           <a:xfrm>
             <a:off x="685800" y="2286000"/>
-            <a:ext cx="1828800" cy="365760"/>
+            <a:ext cx="1828800" cy="457200"/>
           </a:xfrm>
           <a:prstGeom prst="rect">
             <a:avLst/>
@@ -36384,13 +36384,13 @@
           <a:p>
             <a:pPr algn="l"/>
             <a:r>
-              <a:rPr sz="1300" b="1" i="0">
+              <a:rPr sz="1200" b="1" i="0">
                 <a:solidFill>
                   <a:srgbClr val="141B2D"/>
                 </a:solidFill>
                 <a:latin typeface="Calibri"/>
               </a:rPr>
-              <a:t>Onboard in minutes</a:t>
+              <a:t>Understand before touching</a:t>
             </a:r>
           </a:p>
         </p:txBody>
@@ -36403,8 +36403,8 @@
         </p:nvSpPr>
         <p:spPr>
           <a:xfrm>
-            <a:off x="685800" y="2697480"/>
-            <a:ext cx="1828800" cy="2377440"/>
+            <a:off x="685800" y="2788920"/>
+            <a:ext cx="1828800" cy="2286000"/>
           </a:xfrm>
           <a:prstGeom prst="rect">
             <a:avLst/>
@@ -36425,7 +36425,7 @@
                 </a:solidFill>
                 <a:latin typeface="Calibri"/>
               </a:rPr>
-              <a:t>Open the Devin Wiki for DataProfiler: data readers, profilers, the ML labeler pipeline, report formats. Ask Devin: 'How does report() choose an output format and where are formats tested?'</a:t>
+              <a:t>Open the Devin Wiki for hygieia-core / api: modules, the core-to-api dependency, build and test flow. Ask: 'What breaks when this moves to Java 17?'</a:t>
             </a:r>
           </a:p>
         </p:txBody>
@@ -36460,7 +36460,7 @@
                 </a:solidFill>
                 <a:latin typeface="Calibri"/>
               </a:rPr>
-              <a:t>Ties to: Two engineering cultures; onboarding</a:t>
+              <a:t>Ties to: Two engineering cultures; legacy knowledge</a:t>
             </a:r>
           </a:p>
         </p:txBody>
@@ -36577,13 +36577,13 @@
           <a:p>
             <a:pPr algn="l"/>
             <a:r>
-              <a:rPr sz="1500" b="1" i="0">
+              <a:rPr sz="1300" b="1" i="0">
                 <a:solidFill>
                   <a:srgbClr val="FFFFFF"/>
                 </a:solidFill>
                 <a:latin typeface="Calibri"/>
               </a:rPr>
-              <a:t>2  Session</a:t>
+              <a:t>2  Playbook + Session</a:t>
             </a:r>
           </a:p>
         </p:txBody>
@@ -36597,7 +36597,7 @@
         <p:spPr>
           <a:xfrm>
             <a:off x="2926080" y="2286000"/>
-            <a:ext cx="1828800" cy="365760"/>
+            <a:ext cx="1828800" cy="457200"/>
           </a:xfrm>
           <a:prstGeom prst="rect">
             <a:avLst/>
@@ -36612,13 +36612,13 @@
           <a:p>
             <a:pPr algn="l"/>
             <a:r>
-              <a:rPr sz="1300" b="1" i="0">
+              <a:rPr sz="1200" b="1" i="0">
                 <a:solidFill>
                   <a:srgbClr val="141B2D"/>
                 </a:solidFill>
                 <a:latin typeface="Calibri"/>
               </a:rPr>
-              <a:t>Ticket to PR</a:t>
+              <a:t>Upgrade from a playbook</a:t>
             </a:r>
           </a:p>
         </p:txBody>
@@ -36631,8 +36631,8 @@
         </p:nvSpPr>
         <p:spPr>
           <a:xfrm>
-            <a:off x="2926080" y="2697480"/>
-            <a:ext cx="1828800" cy="2377440"/>
+            <a:off x="2926080" y="2788920"/>
+            <a:ext cx="1828800" cy="2286000"/>
           </a:xfrm>
           <a:prstGeom prst="rect">
             <a:avLst/>
@@ -36653,7 +36653,7 @@
                 </a:solidFill>
                 <a:latin typeface="Calibri"/>
               </a:rPr>
-              <a:t>From Slack: '@Devin add a `markdown` output_format to Profiler.report() alongside pretty/compact/flat, with tests and CHANGELOG entry.' Devin plans, edits, runs pytest + pre-commit, opens a PR.</a:t>
+              <a:t>Run the java17_upgrade playbook on the forks: baseline on 11, upgrade core, mvn install, then api; fix plugins and tests, keep Boot 2.x, one PR per repo.</a:t>
             </a:r>
           </a:p>
         </p:txBody>
@@ -36688,7 +36688,7 @@
                 </a:solidFill>
                 <a:latin typeface="Calibri"/>
               </a:rPr>
-              <a:t>Ties to: Data governance tooling; AI mandate</a:t>
+              <a:t>Ties to: Discover integration; modernization at scale</a:t>
             </a:r>
           </a:p>
         </p:txBody>
@@ -36805,7 +36805,7 @@
           <a:p>
             <a:pPr algn="l"/>
             <a:r>
-              <a:rPr sz="1500" b="1" i="0">
+              <a:rPr sz="1300" b="1" i="0">
                 <a:solidFill>
                   <a:srgbClr val="FFFFFF"/>
                 </a:solidFill>
@@ -36825,7 +36825,7 @@
         <p:spPr>
           <a:xfrm>
             <a:off x="5166360" y="2286000"/>
-            <a:ext cx="1828800" cy="365760"/>
+            <a:ext cx="1828800" cy="457200"/>
           </a:xfrm>
           <a:prstGeom prst="rect">
             <a:avLst/>
@@ -36840,7 +36840,7 @@
           <a:p>
             <a:pPr algn="l"/>
             <a:r>
-              <a:rPr sz="1300" b="1" i="0">
+              <a:rPr sz="1200" b="1" i="0">
                 <a:solidFill>
                   <a:srgbClr val="141B2D"/>
                 </a:solidFill>
@@ -36859,8 +36859,8 @@
         </p:nvSpPr>
         <p:spPr>
           <a:xfrm>
-            <a:off x="5166360" y="2697480"/>
-            <a:ext cx="1828800" cy="2377440"/>
+            <a:off x="5166360" y="2788920"/>
+            <a:ext cx="1828800" cy="2286000"/>
           </a:xfrm>
           <a:prstGeom prst="rect">
             <a:avLst/>
@@ -36881,7 +36881,7 @@
                 </a:solidFill>
                 <a:latin typeface="Calibri"/>
               </a:rPr>
-              <a:t>Devin Review comments on the PR: edge cases (nested stats, None values), type hints, style vs. pre-commit rules. Show a finding and the fix.</a:t>
+              <a:t>Devin Review on the PRs: plugin version choices, test rewrites vs. JVM flags, leaked test deps. Show a finding and the fix.</a:t>
             </a:r>
           </a:p>
         </p:txBody>
@@ -36916,7 +36916,7 @@
                 </a:solidFill>
                 <a:latin typeface="Calibri"/>
               </a:rPr>
-              <a:t>Ties to: Compliance evidence; quality</a:t>
+              <a:t>Ties to: AI-readiness: review capacity</a:t>
             </a:r>
           </a:p>
         </p:txBody>
@@ -37033,7 +37033,7 @@
           <a:p>
             <a:pPr algn="l"/>
             <a:r>
-              <a:rPr sz="1500" b="1" i="0">
+              <a:rPr sz="1300" b="1" i="0">
                 <a:solidFill>
                   <a:srgbClr val="FFFFFF"/>
                 </a:solidFill>
@@ -37053,7 +37053,7 @@
         <p:spPr>
           <a:xfrm>
             <a:off x="7406640" y="2286000"/>
-            <a:ext cx="1828800" cy="365760"/>
+            <a:ext cx="1828800" cy="457200"/>
           </a:xfrm>
           <a:prstGeom prst="rect">
             <a:avLst/>
@@ -37068,7 +37068,7 @@
           <a:p>
             <a:pPr algn="l"/>
             <a:r>
-              <a:rPr sz="1300" b="1" i="0">
+              <a:rPr sz="1200" b="1" i="0">
                 <a:solidFill>
                   <a:srgbClr val="141B2D"/>
                 </a:solidFill>
@@ -37087,8 +37087,8 @@
         </p:nvSpPr>
         <p:spPr>
           <a:xfrm>
-            <a:off x="7406640" y="2697480"/>
-            <a:ext cx="1828800" cy="2377440"/>
+            <a:off x="7406640" y="2788920"/>
+            <a:ext cx="1828800" cy="2286000"/>
           </a:xfrm>
           <a:prstGeom prst="rect">
             <a:avLst/>
@@ -37109,7 +37109,7 @@
                 </a:solidFill>
                 <a:latin typeface="Calibri"/>
               </a:rPr>
-              <a:t>Show a scheduled automation: weekly pip-audit / dependency sweep on the repo that opens PRs and posts a Slack summary.</a:t>
+              <a:t>Scheduled automation: weekly Maven dependency / CVE sweep (versions:display-dependency-updates, OWASP check) that opens PRs and posts to Slack.</a:t>
             </a:r>
           </a:p>
         </p:txBody>
@@ -37261,7 +37261,7 @@
           <a:p>
             <a:pPr algn="l"/>
             <a:r>
-              <a:rPr sz="1500" b="1" i="0">
+              <a:rPr sz="1300" b="1" i="0">
                 <a:solidFill>
                   <a:srgbClr val="FFFFFF"/>
                 </a:solidFill>
@@ -37281,7 +37281,7 @@
         <p:spPr>
           <a:xfrm>
             <a:off x="9646920" y="2286000"/>
-            <a:ext cx="1828800" cy="365760"/>
+            <a:ext cx="1828800" cy="457200"/>
           </a:xfrm>
           <a:prstGeom prst="rect">
             <a:avLst/>
@@ -37296,7 +37296,7 @@
           <a:p>
             <a:pPr algn="l"/>
             <a:r>
-              <a:rPr sz="1300" b="1" i="0">
+              <a:rPr sz="1200" b="1" i="0">
                 <a:solidFill>
                   <a:srgbClr val="141B2D"/>
                 </a:solidFill>
@@ -37315,8 +37315,8 @@
         </p:nvSpPr>
         <p:spPr>
           <a:xfrm>
-            <a:off x="9646920" y="2697480"/>
-            <a:ext cx="1828800" cy="2377440"/>
+            <a:off x="9646920" y="2788920"/>
+            <a:ext cx="1828800" cy="2286000"/>
           </a:xfrm>
           <a:prstGeom prst="rect">
             <a:avLst/>
@@ -37337,7 +37337,7 @@
                 </a:solidFill>
                 <a:latin typeface="Calibri"/>
               </a:rPr>
-              <a:t>Settings tour: SSO/SCIM, repo scoping, scoped GitHub App, secrets vault, session audit log, VPC deployment, data retention, no training on code.</a:t>
+              <a:t>Settings tour: SSO/SCIM, repo scoping, scoped GitHub App, secrets vault, replayable session log, VPC option, no training on code.</a:t>
             </a:r>
           </a:p>
         </p:txBody>
@@ -37407,7 +37407,7 @@
                 </a:solidFill>
                 <a:latin typeface="Calibri"/>
               </a:rPr>
-              <a:t>Integrations shown throughout: Slack trigger, GitHub PR, CI status. Backup: pre-recorded session if live run is slow.</a:t>
+              <a:t>Integrations shown throughout: Slack trigger, GitHub PRs, CI status. Backup: completed upgrade sessions and merged PRs.</a:t>
             </a:r>
           </a:p>
         </p:txBody>

</xml_diff>